<commit_message>
Regenerate report and presentation with student details
Co-Authored-By: Claude Opus 5.5 <noreply@anthropic.com>
</commit_message>
<xml_diff>
--- a/deliverables/VaaniSetu_Presentation.pptx
+++ b/deliverables/VaaniSetu_Presentation.pptx
@@ -516,7 +516,7 @@
           <a:p>
             <a:r>
               <a:rPr lang="en-US" dirty="0"/>
-              <a:t>Introduce the team and the project. VaaniSetu means 'bridge of voice'. It turns a photo of any document into a spoken explanation in the listener's own language, built entirely on serverless AWS services.</a:t>
+              <a:t>Introduce yourself and the project. VaaniSetu means 'bridge of voice'. It turns a photo of any document into a spoken explanation in the listener's own language, built entirely on serverless AWS services.</a:t>
             </a:r>
             <a:endParaRPr lang="en-US" dirty="0"/>
           </a:p>
@@ -1396,7 +1396,7 @@
           <a:p>
             <a:r>
               <a:rPr lang="en-US" dirty="0"/>
-              <a:t>Walk through a single request. The photo never passes through the API: it goes straight to S3 with a pre-signed URL, which avoids API payload limits. Rekognition is a cheap gate so we do not pay for an AI call on a blank photo. Bedrock does the heavy lifting in one multimodal call. Polly speaks it, and DynamoDB stores the record.</a:t>
+              <a:t>Walk through a single request. The photo never passes through the API: it goes straight to S3 with a pre-signed URL, which avoids API payload limits. Rekognition is a cheap gate so there is no charge for an AI call on a blank photo. Bedrock does the heavy lifting in one multimodal call. Polly speaks it, and DynamoDB stores the record.</a:t>
             </a:r>
             <a:endParaRPr lang="en-US" dirty="0"/>
           </a:p>
@@ -2445,16 +2445,16 @@
         <p:spPr>
           <a:xfrm>
             <a:off x="548640" y="2423160"/>
-            <a:ext cx="8046720" cy="320040"/>
-          </a:xfrm>
-          <a:prstGeom prst="rect">
-            <a:avLst/>
-          </a:prstGeom>
-          <a:noFill/>
-          <a:ln/>
-        </p:spPr>
-        <p:txBody>
-          <a:bodyPr wrap="square" lIns="0" tIns="0" rIns="0" bIns="0" rtlCol="0" anchor="ctr"/>
+            <a:ext cx="5852160" cy="502920"/>
+          </a:xfrm>
+          <a:prstGeom prst="rect">
+            <a:avLst/>
+          </a:prstGeom>
+          <a:noFill/>
+          <a:ln/>
+        </p:spPr>
+        <p:txBody>
+          <a:bodyPr wrap="square" lIns="0" tIns="0" rIns="0" bIns="0" rtlCol="0" anchor="t"/>
           <a:lstStyle/>
           <a:p>
             <a:pPr indent="0" marL="0">
@@ -2528,7 +2528,7 @@
                 <a:ea typeface="Calibri" pitchFamily="34" charset="-122"/>
                 <a:cs typeface="Calibri" pitchFamily="34" charset="-120"/>
               </a:rPr>
-              <a:t>Student Name1 (App ID)  ·  Student Name2 (App ID)  ·  Student Name3 (App ID)</a:t>
+              <a:t>Mohak Mandwani (App ID: 2406506)</a:t>
             </a:r>
             <a:endParaRPr lang="en-US" sz="1200" dirty="0"/>
           </a:p>
@@ -4651,7 +4651,7 @@
                 <a:ea typeface="Cambria" pitchFamily="34" charset="-122"/>
                 <a:cs typeface="Cambria" pitchFamily="34" charset="-120"/>
               </a:rPr>
-              <a:t>Challenges we solved</a:t>
+              <a:t>Challenges solved</a:t>
             </a:r>
             <a:endParaRPr lang="en-US" sz="3000" dirty="0"/>
           </a:p>
@@ -4729,7 +4729,7 @@
                 <a:ea typeface="Cambria" pitchFamily="34" charset="-122"/>
                 <a:cs typeface="Cambria" pitchFamily="34" charset="-120"/>
               </a:rPr>
-              <a:t>How we solved it</a:t>
+              <a:t>How it was solved</a:t>
             </a:r>
             <a:endParaRPr lang="en-US" sz="1400" dirty="0"/>
           </a:p>
@@ -5446,7 +5446,7 @@
                 <a:ea typeface="Cambria" pitchFamily="34" charset="-122"/>
                 <a:cs typeface="Cambria" pitchFamily="34" charset="-120"/>
               </a:rPr>
-              <a:t>What we achieved</a:t>
+              <a:t>What was achieved</a:t>
             </a:r>
             <a:endParaRPr lang="en-US" sz="1600" dirty="0"/>
           </a:p>

</xml_diff>

<commit_message>
Regenerate presentation (PPTX, PDF) for Google Cloud
Co-Authored-By: Claude Opus 5.5 <noreply@anthropic.com>
</commit_message>
<xml_diff>
--- a/deliverables/VaaniSetu_Presentation.pptx
+++ b/deliverables/VaaniSetu_Presentation.pptx
@@ -516,7 +516,7 @@
           <a:p>
             <a:r>
               <a:rPr lang="en-US" dirty="0"/>
-              <a:t>Introduce yourself and the project. VaaniSetu means 'bridge of voice'. It turns a photo of any document into a spoken explanation in the listener's own language, built entirely on serverless AWS services.</a:t>
+              <a:t>Introduce yourself and the project. VaaniSetu means 'bridge of voice'. It turns a photo of any document into a spoken explanation in the listener's own language, built entirely on serverless Google Cloud services.</a:t>
             </a:r>
             <a:endParaRPr lang="en-US" dirty="0"/>
           </a:p>
@@ -604,7 +604,7 @@
           <a:p>
             <a:r>
               <a:rPr lang="en-US" dirty="0"/>
-              <a:t>These are AWS Console screenshots of the real deployment: the Lambda function with its API Gateway trigger, the three HTTP routes, the audio files Polly generated in S3, and the stored records in DynamoDB.</a:t>
+              <a:t>These are Google Cloud console screenshots of the real deployment: the Cloud Run function's request metrics, the active API Gateway, the MP3 files Text-to-Speech generated in Cloud Storage, and a stored record in Firestore.</a:t>
             </a:r>
             <a:endParaRPr lang="en-US" dirty="0"/>
           </a:p>
@@ -692,7 +692,7 @@
           <a:p>
             <a:r>
               <a:rPr lang="en-US" dirty="0"/>
-              <a:t>Timings come from the Lambda's own measurements, which are shown in the app under each result. The whole pipeline fits comfortably inside API Gateway's 29-second limit. Because everything is pay-per-use, the app costs nothing when nobody is using it.</a:t>
+              <a:t>Timings come from the function's own measurements, which the app shows under each result. Switching from Gemini 3.8 Flash to 3.5 Flash-Lite with thinking off cut the AI step from about 16 seconds to about 3.5. Because everything is pay-per-use, the app costs nothing when nobody is using it.</a:t>
             </a:r>
             <a:endParaRPr lang="en-US" dirty="0"/>
           </a:p>
@@ -780,7 +780,7 @@
           <a:p>
             <a:r>
               <a:rPr lang="en-US" dirty="0"/>
-              <a:t>Security was a design goal from the start. The browser never holds AWS credentials; it only receives short-lived pre-signed URLs. The IAM policy is scoped to specific resources. Throttling and the Rekognition gate protect the budget.</a:t>
+              <a:t>Security was a design goal from the start. The browser never holds Google credentials; it only receives short-lived signed URLs. Each component has its own service account with only the roles it needs. The instance cap, the budget alert and the Vision gate protect the budget.</a:t>
             </a:r>
             <a:endParaRPr lang="en-US" dirty="0"/>
           </a:p>
@@ -868,7 +868,7 @@
           <a:p>
             <a:r>
               <a:rPr lang="en-US" dirty="0"/>
-              <a:t>Real-world constraints shaped the design. The original plan used Textract, Translate and Comprehend, but the Free-plan account blocks them, so we used a multimodal Bedrock model instead. It turned out simpler and handles more languages.</a:t>
+              <a:t>Real-world constraints shaped the design. The AWS account was suspended, so the whole stack was rebuilt on Google Cloud service for service. Benchmarking six Gemini models found a version four times faster and cheaper. Signing URLs without a private key was solved with the IAM signBlob API.</a:t>
             </a:r>
             <a:endParaRPr lang="en-US" dirty="0"/>
           </a:p>
@@ -1044,7 +1044,7 @@
           <a:p>
             <a:r>
               <a:rPr lang="en-US" dirty="0"/>
-              <a:t>Invite questions. Likely viva topics: why serverless, pre-signed URLs, how IAM least privilege works, why Rekognition runs before Bedrock, and what happens if Bedrock returns malformed JSON.</a:t>
+              <a:t>Invite questions. Likely viva topics: why serverless, how signed URLs work, how service-account least privilege works, why Cloud Vision runs before Gemini, why API Gateway is in Tokyo, and what happens if Gemini returns malformed JSON.</a:t>
             </a:r>
             <a:endParaRPr lang="en-US" dirty="0"/>
           </a:p>
@@ -1308,7 +1308,7 @@
           <a:p>
             <a:r>
               <a:rPr lang="en-US" dirty="0"/>
-              <a:t>Everything runs in the Mumbai region, ap-south-1. The frontend is on Amplify Hosting. The browser talks to API Gateway, which invokes a single Lambda function. Lambda orchestrates Rekognition, Bedrock, Polly, S3 and DynamoDB. IAM restricts permissions and CloudWatch collects logs.</a:t>
+              <a:t>Everything runs in the Mumbai region, asia-south1, except API Gateway, which is not offered there and runs in Tokyo. The frontend is a static website on Cloud Storage. The browser calls API Gateway, which invokes a single Cloud Run function. The function orchestrates Cloud Vision, Gemini on Vertex AI, Text-to-Speech, Cloud Storage and Firestore. Service accounts restrict permissions and Cloud Logging records every request.</a:t>
             </a:r>
             <a:endParaRPr lang="en-US" dirty="0"/>
           </a:p>
@@ -1396,7 +1396,7 @@
           <a:p>
             <a:r>
               <a:rPr lang="en-US" dirty="0"/>
-              <a:t>Walk through a single request. The photo never passes through the API: it goes straight to S3 with a pre-signed URL, which avoids API payload limits. Rekognition is a cheap gate so there is no charge for an AI call on a blank photo. Bedrock does the heavy lifting in one multimodal call. Polly speaks it, and DynamoDB stores the record.</a:t>
+              <a:t>Walk through a single request. The photo never passes through the API: it goes straight to Cloud Storage with a signed URL. Cloud Vision is a cheap gate, so a blank photo never reaches Gemini. Gemini does the heavy lifting in one multimodal call. Text-to-Speech speaks it, and Firestore stores the record.</a:t>
             </a:r>
             <a:endParaRPr lang="en-US" dirty="0"/>
           </a:p>
@@ -1484,7 +1484,7 @@
           <a:p>
             <a:r>
               <a:rPr lang="en-US" dirty="0"/>
-              <a:t>The rubric asks for at least three cloud services; VaaniSetu uses eight core AWS services plus IAM and CloudWatch, and no Azure services. Every service is serverless or fully managed, so there is nothing to patch and no idle cost.</a:t>
+              <a:t>The rubric asks for at least three cloud services; VaaniSetu uses eight core Google Cloud services plus IAM and Cloud Logging, and no Azure services. Every service is serverless or fully managed, so there is nothing to patch and no idle cost.</a:t>
             </a:r>
             <a:endParaRPr lang="en-US" dirty="0"/>
           </a:p>
@@ -1572,7 +1572,7 @@
           <a:p>
             <a:r>
               <a:rPr lang="en-US" dirty="0"/>
-              <a:t>The backend is Python on Lambda using Boto3. The frontend is plain HTML, CSS and JavaScript with no framework, which keeps it fast. Deployment is automated with the AWS CLI, and the code is on GitHub.</a:t>
+              <a:t>The backend is Python on a Cloud Run function using Google's client libraries, including google-genai for Gemini. The frontend is plain HTML, CSS and JavaScript with no framework, which keeps it fast. Deployment is automated with the gcloud CLI from Cloud Shell, and the code is on GitHub.</a:t>
             </a:r>
             <a:endParaRPr lang="en-US" dirty="0"/>
           </a:p>
@@ -1660,7 +1660,7 @@
           <a:p>
             <a:r>
               <a:rPr lang="en-US" dirty="0"/>
-              <a:t>Live demo: choose the college notice sample, select Hindi and click 'Read it to me'. The tracker lights up S3, Rekognition, Bedrock, Polly and DynamoDB, and the Hindi audio plays automatically.</a:t>
+              <a:t>Live demo: choose the college notice sample, select Hindi and click 'Read it to me'. The tracker lights up Cloud Storage, Cloud Vision, Vertex AI, Text-to-Speech and Firestore, and the Hindi audio plays automatically.</a:t>
             </a:r>
             <a:endParaRPr lang="en-US" dirty="0"/>
           </a:p>
@@ -1748,7 +1748,7 @@
           <a:p>
             <a:r>
               <a:rPr lang="en-US" dirty="0"/>
-              <a:t>This shows cross-language understanding: the input is Hindi and the output is English. Rekognition cannot read Devanagari, so its confidence is low here, but the Bedrock model reads Hindi correctly. That is exactly why Rekognition is used only as a gate.</a:t>
+              <a:t>This shows cross-language understanding: the input is Hindi and the output is English. Cloud Vision reads Devanagari too, with 94% confidence on this bill, and Gemini explains it correctly, including reading the consumer number digit by digit.</a:t>
             </a:r>
             <a:endParaRPr lang="en-US" dirty="0"/>
           </a:p>
@@ -2430,7 +2430,7 @@
                 <a:ea typeface="Calibri" pitchFamily="34" charset="-122"/>
                 <a:cs typeface="Calibri" pitchFamily="34" charset="-120"/>
               </a:rPr>
-              <a:t>An AI-powered multilingual document reader built on AWS</a:t>
+              <a:t>A multilingual AI document reader on Google Cloud</a:t>
             </a:r>
             <a:endParaRPr lang="en-US" sz="1800" dirty="0"/>
           </a:p>
@@ -2469,7 +2469,7 @@
                 <a:ea typeface="Calibri" pitchFamily="34" charset="-122"/>
                 <a:cs typeface="Calibri" pitchFamily="34" charset="-120"/>
               </a:rPr>
-              <a:t>Amazon Bedrock  ·  Amazon Polly  ·  Amazon Rekognition  ·  AWS Lambda  ·  API Gateway  ·  S3  ·  DynamoDB  ·  Amplify</a:t>
+              <a:t>Vertex AI Gemini  ·  Cloud Vision  ·  Text-to-Speech  ·  Cloud Run functions  ·  API Gateway  ·  Cloud Storage  ·  Firestore</a:t>
             </a:r>
             <a:endParaRPr lang="en-US" sz="1100" dirty="0"/>
           </a:p>
@@ -2649,7 +2649,7 @@
                 <a:ea typeface="Cambria" pitchFamily="34" charset="-122"/>
                 <a:cs typeface="Cambria" pitchFamily="34" charset="-120"/>
               </a:rPr>
-              <a:t>Deployed on AWS (ap-south-1)</a:t>
+              <a:t>Deployed on Google Cloud (asia-south1)</a:t>
             </a:r>
             <a:endParaRPr lang="en-US" sz="3000" dirty="0"/>
           </a:p>
@@ -2657,7 +2657,7 @@
       </p:sp>
       <p:pic>
         <p:nvPicPr>
-          <p:cNvPr id="3" name="Image 0" descr="C:\Users\MOHAK\AppData\Roaming\Claude\scratch-workspaces\f2c6d378-d886-42df-9f4c-719dd5cf9513\45ae0831-b88f-478b-b917-cc13a7ce82a4\scratch-2026-09-29-7d1471\vaanisetu\report\screenshots\05-lambda.jpg">    </p:cNvPr>
+          <p:cNvPr id="3" name="Image 0" descr="C:\Users\MOHAK\vaanisetu\report\screenshots\06-cloud-run-function.jpg">    </p:cNvPr>
           <p:cNvPicPr>
             <a:picLocks noChangeAspect="1"/>
           </p:cNvPicPr>
@@ -2719,7 +2719,7 @@
                 <a:ea typeface="Calibri" pitchFamily="34" charset="-122"/>
                 <a:cs typeface="Calibri" pitchFamily="34" charset="-120"/>
               </a:rPr>
-              <a:t>Lambda: vaanisetu-api</a:t>
+              <a:t>Cloud Run function metrics</a:t>
             </a:r>
             <a:endParaRPr lang="en-US" sz="1100" dirty="0"/>
           </a:p>
@@ -2727,7 +2727,7 @@
       </p:sp>
       <p:pic>
         <p:nvPicPr>
-          <p:cNvPr id="5" name="Image 1" descr="C:\Users\MOHAK\AppData\Roaming\Claude\scratch-workspaces\f2c6d378-d886-42df-9f4c-719dd5cf9513\45ae0831-b88f-478b-b917-cc13a7ce82a4\scratch-2026-09-29-7d1471\vaanisetu\report\screenshots\06-api-gateway.jpg">    </p:cNvPr>
+          <p:cNvPr id="5" name="Image 1" descr="C:\Users\MOHAK\vaanisetu\report\screenshots\07-api-gateway.jpg">    </p:cNvPr>
           <p:cNvPicPr>
             <a:picLocks noChangeAspect="1"/>
           </p:cNvPicPr>
@@ -2789,7 +2789,7 @@
                 <a:ea typeface="Calibri" pitchFamily="34" charset="-122"/>
                 <a:cs typeface="Calibri" pitchFamily="34" charset="-120"/>
               </a:rPr>
-              <a:t>API Gateway routes</a:t>
+              <a:t>API Gateway: active</a:t>
             </a:r>
             <a:endParaRPr lang="en-US" sz="1100" dirty="0"/>
           </a:p>
@@ -2797,7 +2797,7 @@
       </p:sp>
       <p:pic>
         <p:nvPicPr>
-          <p:cNvPr id="7" name="Image 2" descr="C:\Users\MOHAK\AppData\Roaming\Claude\scratch-workspaces\f2c6d378-d886-42df-9f4c-719dd5cf9513\45ae0831-b88f-478b-b917-cc13a7ce82a4\scratch-2026-09-29-7d1471\vaanisetu\report\screenshots\07-s3-audio.jpg">    </p:cNvPr>
+          <p:cNvPr id="7" name="Image 2" descr="C:\Users\MOHAK\vaanisetu\report\screenshots\08-cloud-storage-audio.jpg">    </p:cNvPr>
           <p:cNvPicPr>
             <a:picLocks noChangeAspect="1"/>
           </p:cNvPicPr>
@@ -2859,7 +2859,7 @@
                 <a:ea typeface="Calibri" pitchFamily="34" charset="-122"/>
                 <a:cs typeface="Calibri" pitchFamily="34" charset="-120"/>
               </a:rPr>
-              <a:t>S3: Polly MP3 files</a:t>
+              <a:t>Cloud Storage: MP3 files</a:t>
             </a:r>
             <a:endParaRPr lang="en-US" sz="1100" dirty="0"/>
           </a:p>
@@ -2867,7 +2867,7 @@
       </p:sp>
       <p:pic>
         <p:nvPicPr>
-          <p:cNvPr id="9" name="Image 3" descr="C:\Users\MOHAK\AppData\Roaming\Claude\scratch-workspaces\f2c6d378-d886-42df-9f4c-719dd5cf9513\45ae0831-b88f-478b-b917-cc13a7ce82a4\scratch-2026-09-29-7d1471\vaanisetu\report\screenshots\08-dynamodb.jpg">    </p:cNvPr>
+          <p:cNvPr id="9" name="Image 3" descr="C:\Users\MOHAK\vaanisetu\report\screenshots\09-firestore.jpg">    </p:cNvPr>
           <p:cNvPicPr>
             <a:picLocks noChangeAspect="1"/>
           </p:cNvPicPr>
@@ -2929,7 +2929,7 @@
                 <a:ea typeface="Calibri" pitchFamily="34" charset="-122"/>
                 <a:cs typeface="Calibri" pitchFamily="34" charset="-120"/>
               </a:rPr>
-              <a:t>DynamoDB items</a:t>
+              <a:t>Firestore record</a:t>
             </a:r>
             <a:endParaRPr lang="en-US" sz="1100" dirty="0"/>
           </a:p>
@@ -3110,7 +3110,7 @@
                 <a:ea typeface="Cambria" pitchFamily="34" charset="-122"/>
                 <a:cs typeface="Cambria" pitchFamily="34" charset="-120"/>
               </a:rPr>
-              <a:t>~1 s</a:t>
+              <a:t>~1.5 s</a:t>
             </a:r>
             <a:endParaRPr lang="en-US" sz="4400" dirty="0"/>
           </a:p>
@@ -3149,7 +3149,7 @@
                 <a:ea typeface="Calibri" pitchFamily="34" charset="-122"/>
                 <a:cs typeface="Calibri" pitchFamily="34" charset="-120"/>
               </a:rPr>
-              <a:t>Rekognition text check</a:t>
+              <a:t>Cloud Vision text check</a:t>
             </a:r>
             <a:endParaRPr lang="en-US" sz="1250" dirty="0"/>
           </a:p>
@@ -3188,7 +3188,7 @@
                 <a:ea typeface="Cambria" pitchFamily="34" charset="-122"/>
                 <a:cs typeface="Cambria" pitchFamily="34" charset="-120"/>
               </a:rPr>
-              <a:t>~4 s</a:t>
+              <a:t>~3.5 s</a:t>
             </a:r>
             <a:endParaRPr lang="en-US" sz="4400" dirty="0"/>
           </a:p>
@@ -3227,7 +3227,7 @@
                 <a:ea typeface="Calibri" pitchFamily="34" charset="-122"/>
                 <a:cs typeface="Calibri" pitchFamily="34" charset="-120"/>
               </a:rPr>
-              <a:t>Bedrock understanding</a:t>
+              <a:t>Gemini understanding</a:t>
             </a:r>
             <a:endParaRPr lang="en-US" sz="1250" dirty="0"/>
           </a:p>
@@ -3305,7 +3305,7 @@
                 <a:ea typeface="Calibri" pitchFamily="34" charset="-122"/>
                 <a:cs typeface="Calibri" pitchFamily="34" charset="-120"/>
               </a:rPr>
-              <a:t>Polly neural speech</a:t>
+              <a:t>Text-to-Speech</a:t>
             </a:r>
             <a:endParaRPr lang="en-US" sz="1250" dirty="0"/>
           </a:p>
@@ -3344,7 +3344,7 @@
                 <a:ea typeface="Cambria" pitchFamily="34" charset="-122"/>
                 <a:cs typeface="Cambria" pitchFamily="34" charset="-120"/>
               </a:rPr>
-              <a:t>~10 s</a:t>
+              <a:t>~11 s</a:t>
             </a:r>
             <a:endParaRPr lang="en-US" sz="4400" dirty="0"/>
           </a:p>
@@ -3583,7 +3583,7 @@
                 <a:ea typeface="Calibri" pitchFamily="34" charset="-122"/>
                 <a:cs typeface="Calibri" pitchFamily="34" charset="-120"/>
               </a:rPr>
-              <a:t>AWS services</a:t>
+              <a:t>Google Cloud services</a:t>
             </a:r>
             <a:endParaRPr lang="en-US" sz="1400" dirty="0"/>
           </a:p>
@@ -3913,7 +3913,7 @@
                 <a:ea typeface="Calibri" pitchFamily="34" charset="-122"/>
                 <a:cs typeface="Calibri" pitchFamily="34" charset="-120"/>
               </a:rPr>
-              <a:t>S3 public access blocked, SSE-S3 encryption at rest, uploads expire after 30 days</a:t>
+              <a:t>Public access prevention enforced, encrypted at rest, uploads deleted after 30 days</a:t>
             </a:r>
             <a:endParaRPr lang="en-US" sz="1150" dirty="0"/>
           </a:p>
@@ -4001,7 +4001,7 @@
                 <a:ea typeface="Cambria" pitchFamily="34" charset="-122"/>
                 <a:cs typeface="Cambria" pitchFamily="34" charset="-120"/>
               </a:rPr>
-              <a:t>Pre-signed URLs</a:t>
+              <a:t>Signed URLs</a:t>
             </a:r>
             <a:endParaRPr lang="en-US" sz="1500" dirty="0"/>
           </a:p>
@@ -4040,7 +4040,7 @@
                 <a:ea typeface="Calibri" pitchFamily="34" charset="-122"/>
                 <a:cs typeface="Calibri" pitchFamily="34" charset="-120"/>
               </a:rPr>
-              <a:t>Browser gets 5-minute upload and 1-hour download links, never AWS keys</a:t>
+              <a:t>Browser gets 5-minute upload and 1-hour download links, never Google credentials</a:t>
             </a:r>
             <a:endParaRPr lang="en-US" sz="1150" dirty="0"/>
           </a:p>
@@ -4167,7 +4167,7 @@
                 <a:ea typeface="Calibri" pitchFamily="34" charset="-122"/>
                 <a:cs typeface="Calibri" pitchFamily="34" charset="-120"/>
               </a:rPr>
-              <a:t>Lambda role may only use one bucket, one table, and the exact AI actions</a:t>
+              <a:t>Separate service accounts for function, gateway and builds, each with only the roles it needs</a:t>
             </a:r>
             <a:endParaRPr lang="en-US" sz="1150" dirty="0"/>
           </a:p>
@@ -4255,7 +4255,7 @@
                 <a:ea typeface="Cambria" pitchFamily="34" charset="-122"/>
                 <a:cs typeface="Cambria" pitchFamily="34" charset="-120"/>
               </a:rPr>
-              <a:t>Throttling</a:t>
+              <a:t>Spend guard</a:t>
             </a:r>
             <a:endParaRPr lang="en-US" sz="1500" dirty="0"/>
           </a:p>
@@ -4294,7 +4294,7 @@
                 <a:ea typeface="Calibri" pitchFamily="34" charset="-122"/>
                 <a:cs typeface="Calibri" pitchFamily="34" charset="-120"/>
               </a:rPr>
-              <a:t>API Gateway limits 10 req/s (burst 20) to protect the budget</a:t>
+              <a:t>At most 3 function instances; ₹400 budget alert at 50/90/100%</a:t>
             </a:r>
             <a:endParaRPr lang="en-US" sz="1150" dirty="0"/>
           </a:p>
@@ -4421,7 +4421,7 @@
                 <a:ea typeface="Calibri" pitchFamily="34" charset="-122"/>
                 <a:cs typeface="Calibri" pitchFamily="34" charset="-120"/>
               </a:rPr>
-              <a:t>Rekognition blocks non-document photos before any AI charge</a:t>
+              <a:t>Cloud Vision blocks non-document photos before any Gemini charge</a:t>
             </a:r>
             <a:endParaRPr lang="en-US" sz="1150" dirty="0"/>
           </a:p>
@@ -4509,7 +4509,7 @@
                 <a:ea typeface="Cambria" pitchFamily="34" charset="-122"/>
                 <a:cs typeface="Cambria" pitchFamily="34" charset="-120"/>
               </a:rPr>
-              <a:t>Serverless</a:t>
+              <a:t>Scales to zero</a:t>
             </a:r>
             <a:endParaRPr lang="en-US" sz="1500" dirty="0"/>
           </a:p>
@@ -4548,7 +4548,7 @@
                 <a:ea typeface="Calibri" pitchFamily="34" charset="-122"/>
                 <a:cs typeface="Calibri" pitchFamily="34" charset="-120"/>
               </a:rPr>
-              <a:t>No servers to patch; pay only per request</a:t>
+              <a:t>No servers to patch; nothing runs and nothing bills while idle</a:t>
             </a:r>
             <a:endParaRPr lang="en-US" sz="1150" dirty="0"/>
           </a:p>
@@ -4832,7 +4832,7 @@
                 <a:ea typeface="Calibri" pitchFamily="34" charset="-122"/>
                 <a:cs typeface="Calibri" pitchFamily="34" charset="-120"/>
               </a:rPr>
-              <a:t>Textract, Translate &amp; Comprehend blocked on the AWS Free plan</a:t>
+              <a:t>The AWS account was suspended mid-project</a:t>
             </a:r>
             <a:endParaRPr lang="en-US" sz="1200" dirty="0"/>
           </a:p>
@@ -4871,7 +4871,7 @@
                 <a:ea typeface="Calibri" pitchFamily="34" charset="-122"/>
                 <a:cs typeface="Calibri" pitchFamily="34" charset="-120"/>
               </a:rPr>
-              <a:t>One multimodal Bedrock model reads, translates and summarises in a single call</a:t>
+              <a:t>Rebuilt on Google Cloud with one re-runnable deploy script; AWS version kept in Git history</a:t>
             </a:r>
             <a:endParaRPr lang="en-US" sz="1200" dirty="0"/>
           </a:p>
@@ -4974,7 +4974,7 @@
                 <a:ea typeface="Calibri" pitchFamily="34" charset="-122"/>
                 <a:cs typeface="Calibri" pitchFamily="34" charset="-120"/>
               </a:rPr>
-              <a:t>CloudFront needs account verification for new accounts</a:t>
+              <a:t>Gemini 3.8 Flash took 16-24 s per document</a:t>
             </a:r>
             <a:endParaRPr lang="en-US" sz="1200" dirty="0"/>
           </a:p>
@@ -5013,7 +5013,7 @@
                 <a:ea typeface="Calibri" pitchFamily="34" charset="-122"/>
                 <a:cs typeface="Calibri" pitchFamily="34" charset="-120"/>
               </a:rPr>
-              <a:t>Hosted the frontend on AWS Amplify Hosting (HTTPS + CDN)</a:t>
+              <a:t>Benchmarked 6 models: 3.5 Flash-Lite with thinking off takes ~3.5 s and costs less</a:t>
             </a:r>
             <a:endParaRPr lang="en-US" sz="1200" dirty="0"/>
           </a:p>
@@ -5116,7 +5116,7 @@
                 <a:ea typeface="Calibri" pitchFamily="34" charset="-122"/>
                 <a:cs typeface="Calibri" pitchFamily="34" charset="-120"/>
               </a:rPr>
-              <a:t>Rekognition reads Latin script only</a:t>
+              <a:t>API Gateway is not offered in Mumbai</a:t>
             </a:r>
             <a:endParaRPr lang="en-US" sz="1200" dirty="0"/>
           </a:p>
@@ -5155,7 +5155,7 @@
                 <a:ea typeface="Calibri" pitchFamily="34" charset="-122"/>
                 <a:cs typeface="Calibri" pitchFamily="34" charset="-120"/>
               </a:rPr>
-              <a:t>Used as a fast "is there text?" gate; Bedrock handles Hindi and other scripts</a:t>
+              <a:t>Gateway runs in Tokyo (asia-northeast1) and routes to the function in Mumbai</a:t>
             </a:r>
             <a:endParaRPr lang="en-US" sz="1200" dirty="0"/>
           </a:p>
@@ -5258,7 +5258,7 @@
                 <a:ea typeface="Calibri" pitchFamily="34" charset="-122"/>
                 <a:cs typeface="Calibri" pitchFamily="34" charset="-120"/>
               </a:rPr>
-              <a:t>API Gateway's 29-second limit</a:t>
+              <a:t>Cloud Run has no private key to sign URLs</a:t>
             </a:r>
             <a:endParaRPr lang="en-US" sz="1200" dirty="0"/>
           </a:p>
@@ -5297,7 +5297,7 @@
                 <a:ea typeface="Calibri" pitchFamily="34" charset="-122"/>
                 <a:cs typeface="Calibri" pitchFamily="34" charset="-120"/>
               </a:rPr>
-              <a:t>Direct-to-S3 uploads and a pipeline that finishes in about 10 seconds</a:t>
+              <a:t>The function signs Storage URLs via the IAM signBlob API with its own service account</a:t>
             </a:r>
             <a:endParaRPr lang="en-US" sz="1200" dirty="0"/>
           </a:p>
@@ -5510,7 +5510,7 @@
                 <a:ea typeface="Calibri" pitchFamily="34" charset="-122"/>
                 <a:cs typeface="Calibri" pitchFamily="34" charset="-120"/>
               </a:rPr>
-              <a:t>8 core AWS services + IAM and CloudWatch, integrated end to end</a:t>
+              <a:t>8 core Google Cloud services + IAM and Cloud Logging, integrated end to end</a:t>
             </a:r>
             <a:endParaRPr lang="en-US" sz="1350" dirty="0"/>
           </a:p>
@@ -5613,7 +5613,7 @@
                 <a:ea typeface="Calibri" pitchFamily="34" charset="-122"/>
                 <a:cs typeface="Calibri" pitchFamily="34" charset="-120"/>
               </a:rPr>
-              <a:t>Multi-page PDFs with SQS / Step Functions</a:t>
+              <a:t>Multi-page PDFs with Pub/Sub and Workflows</a:t>
             </a:r>
             <a:endParaRPr lang="en-US" sz="1350" dirty="0"/>
           </a:p>
@@ -5655,7 +5655,7 @@
                 <a:ea typeface="Calibri" pitchFamily="34" charset="-122"/>
                 <a:cs typeface="Calibri" pitchFamily="34" charset="-120"/>
               </a:rPr>
-              <a:t>Private per-user history with Amazon Cognito</a:t>
+              <a:t>Private per-user history with Firebase Authentication</a:t>
             </a:r>
             <a:endParaRPr lang="en-US" sz="1350" dirty="0"/>
           </a:p>
@@ -5715,7 +5715,7 @@
                 <a:ea typeface="Calibri" pitchFamily="34" charset="-122"/>
                 <a:cs typeface="Calibri" pitchFamily="34" charset="-120"/>
               </a:rPr>
-              <a:t>Live: main.dubqxztshiysh.amplifyapp.com   ·   Code: github.com/17mohak/vaanisetu</a:t>
+              <a:t>Live: storage.googleapis.com/vaanisetu-web-project-2acd026b-3237-497d-89d/index.html   ·   Code: github.com/17mohak/vaanisetu</a:t>
             </a:r>
             <a:endParaRPr lang="en-US" sz="1200" dirty="0"/>
           </a:p>
@@ -6906,7 +6906,7 @@
       </p:sp>
       <p:pic>
         <p:nvPicPr>
-          <p:cNvPr id="16" name="Image 3" descr="C:\Users\MOHAK\AppData\Roaming\Claude\scratch-workspaces\f2c6d378-d886-42df-9f4c-719dd5cf9513\45ae0831-b88f-478b-b917-cc13a7ce82a4\scratch-2026-09-29-7d1471\vaanisetu\report\screenshots\01-home.jpg">    </p:cNvPr>
+          <p:cNvPr id="16" name="Image 3" descr="C:\Users\MOHAK\vaanisetu\report\screenshots\01-home.jpg">    </p:cNvPr>
           <p:cNvPicPr>
             <a:picLocks noChangeAspect="1"/>
           </p:cNvPicPr>
@@ -7079,7 +7079,7 @@
       </p:sp>
       <p:pic>
         <p:nvPicPr>
-          <p:cNvPr id="3" name="Image 0" descr="C:\Users\MOHAK\AppData\Roaming\Claude\scratch-workspaces\f2c6d378-d886-42df-9f4c-719dd5cf9513\45ae0831-b88f-478b-b917-cc13a7ce82a4\scratch-2026-09-29-7d1471\vaanisetu\report\block-diagram.png">    </p:cNvPr>
+          <p:cNvPr id="3" name="Image 0" descr="C:\Users\MOHAK\vaanisetu\report\block-diagram.png">    </p:cNvPr>
           <p:cNvPicPr>
             <a:picLocks noChangeAspect="1"/>
           </p:cNvPicPr>
@@ -7237,7 +7237,7 @@
                 <a:ea typeface="Calibri" pitchFamily="34" charset="-122"/>
                 <a:cs typeface="Calibri" pitchFamily="34" charset="-120"/>
               </a:rPr>
-              <a:t>One photo, five AWS services, about 10 seconds</a:t>
+              <a:t>One photo, five Google Cloud services, about 11 seconds</a:t>
             </a:r>
             <a:endParaRPr lang="en-US" sz="1400" dirty="0"/>
           </a:p>
@@ -7357,7 +7357,7 @@
                 <a:ea typeface="Cambria" pitchFamily="34" charset="-122"/>
                 <a:cs typeface="Cambria" pitchFamily="34" charset="-120"/>
               </a:rPr>
-              <a:t>S3</a:t>
+              <a:t>Cloud Storage</a:t>
             </a:r>
             <a:endParaRPr lang="en-US" sz="1400" dirty="0"/>
           </a:p>
@@ -7396,7 +7396,7 @@
                 <a:ea typeface="Calibri" pitchFamily="34" charset="-122"/>
                 <a:cs typeface="Calibri" pitchFamily="34" charset="-120"/>
               </a:rPr>
-              <a:t>Pre-signed upload</a:t>
+              <a:t>Signed upload</a:t>
             </a:r>
             <a:endParaRPr lang="en-US" sz="1100" dirty="0"/>
           </a:p>
@@ -7575,7 +7575,7 @@
                 <a:ea typeface="Cambria" pitchFamily="34" charset="-122"/>
                 <a:cs typeface="Cambria" pitchFamily="34" charset="-120"/>
               </a:rPr>
-              <a:t>Rekognition</a:t>
+              <a:t>Cloud Vision</a:t>
             </a:r>
             <a:endParaRPr lang="en-US" sz="1400" dirty="0"/>
           </a:p>
@@ -7653,7 +7653,7 @@
                 <a:ea typeface="Calibri" pitchFamily="34" charset="-122"/>
                 <a:cs typeface="Calibri" pitchFamily="34" charset="-120"/>
               </a:rPr>
-              <a:t>DetectText rejects photos with no readable text</a:t>
+              <a:t>Text detection rejects photos with no readable text</a:t>
             </a:r>
             <a:endParaRPr lang="en-US" sz="1050" dirty="0"/>
           </a:p>
@@ -7793,7 +7793,7 @@
                 <a:ea typeface="Cambria" pitchFamily="34" charset="-122"/>
                 <a:cs typeface="Cambria" pitchFamily="34" charset="-120"/>
               </a:rPr>
-              <a:t>Bedrock</a:t>
+              <a:t>Vertex AI</a:t>
             </a:r>
             <a:endParaRPr lang="en-US" sz="1400" dirty="0"/>
           </a:p>
@@ -7871,7 +7871,7 @@
                 <a:ea typeface="Calibri" pitchFamily="34" charset="-122"/>
                 <a:cs typeface="Calibri" pitchFamily="34" charset="-120"/>
               </a:rPr>
-              <a:t>Nova 2 Lite transcribes, explains and translates</a:t>
+              <a:t>Gemini transcribes, explains and translates</a:t>
             </a:r>
             <a:endParaRPr lang="en-US" sz="1050" dirty="0"/>
           </a:p>
@@ -8011,7 +8011,7 @@
                 <a:ea typeface="Cambria" pitchFamily="34" charset="-122"/>
                 <a:cs typeface="Cambria" pitchFamily="34" charset="-120"/>
               </a:rPr>
-              <a:t>Polly</a:t>
+              <a:t>Text-to-Speech</a:t>
             </a:r>
             <a:endParaRPr lang="en-US" sz="1400" dirty="0"/>
           </a:p>
@@ -8089,7 +8089,7 @@
                 <a:ea typeface="Calibri" pitchFamily="34" charset="-122"/>
                 <a:cs typeface="Calibri" pitchFamily="34" charset="-120"/>
               </a:rPr>
-              <a:t>Neural voice produces an MP3, saved to S3</a:t>
+              <a:t>Neural voice produces an MP3, saved to Cloud Storage</a:t>
             </a:r>
             <a:endParaRPr lang="en-US" sz="1050" dirty="0"/>
           </a:p>
@@ -8229,7 +8229,7 @@
                 <a:ea typeface="Cambria" pitchFamily="34" charset="-122"/>
                 <a:cs typeface="Cambria" pitchFamily="34" charset="-120"/>
               </a:rPr>
-              <a:t>DynamoDB</a:t>
+              <a:t>Firestore</a:t>
             </a:r>
             <a:endParaRPr lang="en-US" sz="1400" dirty="0"/>
           </a:p>
@@ -8346,7 +8346,7 @@
                 <a:ea typeface="Calibri" pitchFamily="34" charset="-122"/>
                 <a:cs typeface="Calibri" pitchFamily="34" charset="-120"/>
               </a:rPr>
-              <a:t>API Gateway (HTTP API) → AWS Lambda orchestrates every step  ·  IAM least-privilege role  ·  CloudWatch logs</a:t>
+              <a:t>API Gateway → Cloud Run function orchestrates every step  ·  least-privilege service accounts  ·  Cloud Logging</a:t>
             </a:r>
             <a:endParaRPr lang="en-US" sz="1200" dirty="0"/>
           </a:p>
@@ -8488,7 +8488,7 @@
                 <a:ea typeface="Calibri" pitchFamily="34" charset="-122"/>
                 <a:cs typeface="Calibri" pitchFamily="34" charset="-120"/>
               </a:rPr>
-              <a:t>8 core AWS services plus IAM and CloudWatch, all serverless or fully managed</a:t>
+              <a:t>8 core Google Cloud services plus IAM and Cloud Logging, all serverless or fully managed</a:t>
             </a:r>
             <a:endParaRPr lang="en-US" sz="1400" dirty="0"/>
           </a:p>
@@ -8598,7 +8598,7 @@
                 <a:ea typeface="Cambria" pitchFamily="34" charset="-122"/>
                 <a:cs typeface="Cambria" pitchFamily="34" charset="-120"/>
               </a:rPr>
-              <a:t>Amazon S3</a:t>
+              <a:t>Cloud Storage</a:t>
             </a:r>
             <a:endParaRPr lang="en-US" sz="1250" dirty="0"/>
           </a:p>
@@ -8747,7 +8747,7 @@
                 <a:ea typeface="Cambria" pitchFamily="34" charset="-122"/>
                 <a:cs typeface="Cambria" pitchFamily="34" charset="-120"/>
               </a:rPr>
-              <a:t>AWS Lambda</a:t>
+              <a:t>Cloud Run</a:t>
             </a:r>
             <a:endParaRPr lang="en-US" sz="1250" dirty="0"/>
           </a:p>
@@ -8786,7 +8786,7 @@
                 <a:ea typeface="Calibri" pitchFamily="34" charset="-122"/>
                 <a:cs typeface="Calibri" pitchFamily="34" charset="-120"/>
               </a:rPr>
-              <a:t>Python 3.12 backend orchestrating the AI pipeline</a:t>
+              <a:t>Python 3.12 function orchestrating the AI pipeline</a:t>
             </a:r>
             <a:endParaRPr lang="en-US" sz="950" dirty="0"/>
           </a:p>
@@ -8935,7 +8935,7 @@
                 <a:ea typeface="Calibri" pitchFamily="34" charset="-122"/>
                 <a:cs typeface="Calibri" pitchFamily="34" charset="-120"/>
               </a:rPr>
-              <a:t>HTTP API: /upload-url, /process, /history</a:t>
+              <a:t>OpenAPI routes: /upload-url, /process, /history</a:t>
             </a:r>
             <a:endParaRPr lang="en-US" sz="950" dirty="0"/>
           </a:p>
@@ -9045,7 +9045,7 @@
                 <a:ea typeface="Cambria" pitchFamily="34" charset="-122"/>
                 <a:cs typeface="Cambria" pitchFamily="34" charset="-120"/>
               </a:rPr>
-              <a:t>Amazon Bedrock</a:t>
+              <a:t>Vertex AI</a:t>
             </a:r>
             <a:endParaRPr lang="en-US" sz="1250" dirty="0"/>
           </a:p>
@@ -9084,7 +9084,7 @@
                 <a:ea typeface="Calibri" pitchFamily="34" charset="-122"/>
                 <a:cs typeface="Calibri" pitchFamily="34" charset="-120"/>
               </a:rPr>
-              <a:t>Amazon Nova 2 Lite reads, explains, translates</a:t>
+              <a:t>Gemini 3.5 Flash-Lite reads, explains, translates</a:t>
             </a:r>
             <a:endParaRPr lang="en-US" sz="950" dirty="0"/>
           </a:p>
@@ -9194,7 +9194,7 @@
                 <a:ea typeface="Cambria" pitchFamily="34" charset="-122"/>
                 <a:cs typeface="Cambria" pitchFamily="34" charset="-120"/>
               </a:rPr>
-              <a:t>Rekognition</a:t>
+              <a:t>Cloud Vision</a:t>
             </a:r>
             <a:endParaRPr lang="en-US" sz="1250" dirty="0"/>
           </a:p>
@@ -9233,7 +9233,7 @@
                 <a:ea typeface="Calibri" pitchFamily="34" charset="-122"/>
                 <a:cs typeface="Calibri" pitchFamily="34" charset="-120"/>
               </a:rPr>
-              <a:t>DetectText gate before the AI model runs</a:t>
+              <a:t>Text detection gate before Gemini runs</a:t>
             </a:r>
             <a:endParaRPr lang="en-US" sz="950" dirty="0"/>
           </a:p>
@@ -9343,7 +9343,7 @@
                 <a:ea typeface="Cambria" pitchFamily="34" charset="-122"/>
                 <a:cs typeface="Cambria" pitchFamily="34" charset="-120"/>
               </a:rPr>
-              <a:t>Amazon Polly</a:t>
+              <a:t>Text-to-Speech</a:t>
             </a:r>
             <a:endParaRPr lang="en-US" sz="1250" dirty="0"/>
           </a:p>
@@ -9492,7 +9492,7 @@
                 <a:ea typeface="Cambria" pitchFamily="34" charset="-122"/>
                 <a:cs typeface="Cambria" pitchFamily="34" charset="-120"/>
               </a:rPr>
-              <a:t>DynamoDB</a:t>
+              <a:t>Firestore</a:t>
             </a:r>
             <a:endParaRPr lang="en-US" sz="1250" dirty="0"/>
           </a:p>
@@ -9531,7 +9531,7 @@
                 <a:ea typeface="Calibri" pitchFamily="34" charset="-122"/>
                 <a:cs typeface="Calibri" pitchFamily="34" charset="-120"/>
               </a:rPr>
-              <a:t>On-demand table for document history</a:t>
+              <a:t>Serverless NoSQL history (free tier)</a:t>
             </a:r>
             <a:endParaRPr lang="en-US" sz="950" dirty="0"/>
           </a:p>
@@ -9641,7 +9641,7 @@
                 <a:ea typeface="Cambria" pitchFamily="34" charset="-122"/>
                 <a:cs typeface="Cambria" pitchFamily="34" charset="-120"/>
               </a:rPr>
-              <a:t>Amplify Hosting</a:t>
+              <a:t>Storage hosting</a:t>
             </a:r>
             <a:endParaRPr lang="en-US" sz="1250" dirty="0"/>
           </a:p>
@@ -9680,7 +9680,7 @@
                 <a:ea typeface="Calibri" pitchFamily="34" charset="-122"/>
                 <a:cs typeface="Calibri" pitchFamily="34" charset="-120"/>
               </a:rPr>
-              <a:t>HTTPS hosting + CDN for the web app</a:t>
+              <a:t>HTTPS static website for the web app</a:t>
             </a:r>
             <a:endParaRPr lang="en-US" sz="950" dirty="0"/>
           </a:p>
@@ -9790,7 +9790,7 @@
                 <a:ea typeface="Cambria" pitchFamily="34" charset="-122"/>
                 <a:cs typeface="Cambria" pitchFamily="34" charset="-120"/>
               </a:rPr>
-              <a:t>AWS IAM</a:t>
+              <a:t>IAM</a:t>
             </a:r>
             <a:endParaRPr lang="en-US" sz="1250" dirty="0"/>
           </a:p>
@@ -9829,7 +9829,7 @@
                 <a:ea typeface="Calibri" pitchFamily="34" charset="-122"/>
                 <a:cs typeface="Calibri" pitchFamily="34" charset="-120"/>
               </a:rPr>
-              <a:t>Least-privilege Lambda execution role</a:t>
+              <a:t>Least-privilege service accounts</a:t>
             </a:r>
             <a:endParaRPr lang="en-US" sz="950" dirty="0"/>
           </a:p>
@@ -9939,7 +9939,7 @@
                 <a:ea typeface="Cambria" pitchFamily="34" charset="-122"/>
                 <a:cs typeface="Cambria" pitchFamily="34" charset="-120"/>
               </a:rPr>
-              <a:t>CloudWatch</a:t>
+              <a:t>Cloud Logging</a:t>
             </a:r>
             <a:endParaRPr lang="en-US" sz="1250" dirty="0"/>
           </a:p>
@@ -10169,7 +10169,7 @@
                 <a:ea typeface="Cambria" pitchFamily="34" charset="-122"/>
                 <a:cs typeface="Cambria" pitchFamily="34" charset="-120"/>
               </a:rPr>
-              <a:t>Python 3.12 + Boto3</a:t>
+              <a:t>Python 3.12 + Google Cloud SDKs</a:t>
             </a:r>
             <a:endParaRPr lang="en-US" sz="1500" dirty="0"/>
           </a:p>
@@ -10208,7 +10208,7 @@
                 <a:ea typeface="Calibri" pitchFamily="34" charset="-122"/>
                 <a:cs typeface="Calibri" pitchFamily="34" charset="-120"/>
               </a:rPr>
-              <a:t>Lambda backend calling S3, Rekognition, Bedrock Converse API, Polly and DynamoDB</a:t>
+              <a:t>Cloud Run function calling Storage, Vision, Vertex AI (google-genai), Text-to-Speech and Firestore</a:t>
             </a:r>
             <a:endParaRPr lang="en-US" sz="1150" dirty="0"/>
           </a:p>
@@ -10699,7 +10699,7 @@
                 <a:ea typeface="Cambria" pitchFamily="34" charset="-122"/>
                 <a:cs typeface="Cambria" pitchFamily="34" charset="-120"/>
               </a:rPr>
-              <a:t>AWS CLI + Bash</a:t>
+              <a:t>gcloud CLI + Bash</a:t>
             </a:r>
             <a:endParaRPr lang="en-US" sz="1500" dirty="0"/>
           </a:p>
@@ -10738,7 +10738,7 @@
                 <a:ea typeface="Calibri" pitchFamily="34" charset="-122"/>
                 <a:cs typeface="Calibri" pitchFamily="34" charset="-120"/>
               </a:rPr>
-              <a:t>One repeatable script provisions every resource</a:t>
+              <a:t>One repeatable script, run in Cloud Shell, provisions every resource</a:t>
             </a:r>
             <a:endParaRPr lang="en-US" sz="1150" dirty="0"/>
           </a:p>
@@ -10992,7 +10992,7 @@
                 <a:ea typeface="Calibri" pitchFamily="34" charset="-122"/>
                 <a:cs typeface="Calibri" pitchFamily="34" charset="-120"/>
               </a:rPr>
-              <a:t>API payloads, structured AI output and IAM policies</a:t>
+              <a:t>API payloads, structured AI output and the OpenAPI spec</a:t>
             </a:r>
             <a:endParaRPr lang="en-US" sz="1150" dirty="0"/>
           </a:p>
@@ -11103,7 +11103,7 @@
       </p:sp>
       <p:pic>
         <p:nvPicPr>
-          <p:cNvPr id="3" name="Image 0" descr="C:\Users\MOHAK\AppData\Roaming\Claude\scratch-workspaces\f2c6d378-d886-42df-9f4c-719dd5cf9513\45ae0831-b88f-478b-b917-cc13a7ce82a4\scratch-2026-09-29-7d1471\vaanisetu\report\screenshots\02-result-hindi-notice.jpg">    </p:cNvPr>
+          <p:cNvPr id="3" name="Image 0" descr="C:\Users\MOHAK\vaanisetu\report\screenshots\02-result-hindi-notice.jpg">    </p:cNvPr>
           <p:cNvPicPr>
             <a:picLocks noChangeAspect="1"/>
           </p:cNvPicPr>
@@ -11190,7 +11190,7 @@
                 <a:ea typeface="Calibri" pitchFamily="34" charset="-122"/>
                 <a:cs typeface="Calibri" pitchFamily="34" charset="-120"/>
               </a:rPr>
-              <a:t>Summary written and spoken in Hindi by Polly (Kajal, neural)</a:t>
+              <a:t>Summary written in Hindi and spoken by a neural Text-to-Speech voice</a:t>
             </a:r>
             <a:endParaRPr lang="en-US" sz="1250" dirty="0"/>
           </a:p>
@@ -11253,7 +11253,7 @@
                 <a:ea typeface="Calibri" pitchFamily="34" charset="-122"/>
                 <a:cs typeface="Calibri" pitchFamily="34" charset="-120"/>
               </a:rPr>
-              <a:t>OCR confidence 98.3%</a:t>
+              <a:t>Cloud Vision OCR confidence 98%</a:t>
             </a:r>
             <a:endParaRPr lang="en-US" sz="1250" dirty="0"/>
           </a:p>
@@ -11364,7 +11364,7 @@
       </p:sp>
       <p:pic>
         <p:nvPicPr>
-          <p:cNvPr id="3" name="Image 0" descr="C:\Users\MOHAK\AppData\Roaming\Claude\scratch-workspaces\f2c6d378-d886-42df-9f4c-719dd5cf9513\45ae0831-b88f-478b-b917-cc13a7ce82a4\scratch-2026-09-29-7d1471\vaanisetu\report\screenshots\03-result-english-bill.jpg">    </p:cNvPr>
+          <p:cNvPr id="3" name="Image 0" descr="C:\Users\MOHAK\vaanisetu\report\screenshots\03-result-english-bill.jpg">    </p:cNvPr>
           <p:cNvPicPr>
             <a:picLocks noChangeAspect="1"/>
           </p:cNvPicPr>
@@ -11395,7 +11395,7 @@
       </p:pic>
       <p:pic>
         <p:nvPicPr>
-          <p:cNvPr id="4" name="Image 1" descr="C:\Users\MOHAK\AppData\Roaming\Claude\scratch-workspaces\f2c6d378-d886-42df-9f4c-719dd5cf9513\45ae0831-b88f-478b-b917-cc13a7ce82a4\scratch-2026-09-29-7d1471\vaanisetu\report\screenshots\04-history.jpg">    </p:cNvPr>
+          <p:cNvPr id="4" name="Image 1" descr="C:\Users\MOHAK\vaanisetu\report\screenshots\05-history.jpg">    </p:cNvPr>
           <p:cNvPicPr>
             <a:picLocks noChangeAspect="1"/>
           </p:cNvPicPr>
@@ -11496,7 +11496,7 @@
                 <a:ea typeface="Calibri" pitchFamily="34" charset="-122"/>
                 <a:cs typeface="Calibri" pitchFamily="34" charset="-120"/>
               </a:rPr>
-              <a:t>Every result is saved in DynamoDB. Tapping a card replays the explanation and audio.</a:t>
+              <a:t>Every result is saved in Firestore. Tapping a card replays the explanation and audio.</a:t>
             </a:r>
             <a:endParaRPr lang="en-US" sz="1200" dirty="0"/>
           </a:p>

</xml_diff>